<commit_message>
Revert "Merge branch 'develop' into jm-dev-branch"
This reverts commit e0df5f97019b726bbbe47779f4672e4f5f006d77, reversing
changes made to 0437e309b40217feaf0106cf6e36f1d08a3bb5ba.
</commit_message>
<xml_diff>
--- a/app/resource/Imagery.pptx
+++ b/app/resource/Imagery.pptx
@@ -6,8 +6,6 @@
   </p:sldMasterIdLst>
   <p:sldIdLst>
     <p:sldId id="256" r:id="rId2"/>
-    <p:sldId id="257" r:id="rId3"/>
-    <p:sldId id="258" r:id="rId4"/>
   </p:sldIdLst>
   <p:sldSz cx="12192000" cy="6858000"/>
   <p:notesSz cx="6858000" cy="9144000"/>
@@ -106,11 +104,6 @@
       </a:defRPr>
     </a:lvl9pPr>
   </p:defaultTextStyle>
-  <p:extLst>
-    <p:ext uri="{EFAFB233-063F-42B5-8137-9DF3F51BA10A}">
-      <p15:sldGuideLst xmlns:p15="http://schemas.microsoft.com/office/powerpoint/2012/main"/>
-    </p:ext>
-  </p:extLst>
 </p:presentation>
 </file>
 
@@ -156,9 +149,10 @@
           </a:lstStyle>
           <a:p>
             <a:r>
-              <a:rPr lang="en-US"/>
+              <a:rPr lang="en-US" smtClean="0"/>
               <a:t>Click to edit Master title style</a:t>
             </a:r>
+            <a:endParaRPr lang="en-US"/>
           </a:p>
         </p:txBody>
       </p:sp>
@@ -220,9 +214,10 @@
           </a:lstStyle>
           <a:p>
             <a:r>
-              <a:rPr lang="en-US"/>
+              <a:rPr lang="en-US" smtClean="0"/>
               <a:t>Click to edit Master subtitle style</a:t>
             </a:r>
+            <a:endParaRPr lang="en-US"/>
           </a:p>
         </p:txBody>
       </p:sp>
@@ -243,7 +238,7 @@
           <a:p>
             <a:fld id="{5CD31FE7-93CC-4E45-AF1D-A5855231BD86}" type="datetimeFigureOut">
               <a:rPr lang="en-US" smtClean="0"/>
-              <a:t>10/20/2025</a:t>
+              <a:t>1/13/2016</a:t>
             </a:fld>
             <a:endParaRPr lang="en-US"/>
           </a:p>
@@ -337,9 +332,10 @@
           <a:lstStyle/>
           <a:p>
             <a:r>
-              <a:rPr lang="en-US"/>
+              <a:rPr lang="en-US" smtClean="0"/>
               <a:t>Click to edit Master title style</a:t>
             </a:r>
+            <a:endParaRPr lang="en-US"/>
           </a:p>
         </p:txBody>
       </p:sp>
@@ -360,37 +356,38 @@
           <a:p>
             <a:pPr lvl="0"/>
             <a:r>
-              <a:rPr lang="en-US"/>
+              <a:rPr lang="en-US" smtClean="0"/>
               <a:t>Click to edit Master text styles</a:t>
             </a:r>
           </a:p>
           <a:p>
             <a:pPr lvl="1"/>
             <a:r>
-              <a:rPr lang="en-US"/>
+              <a:rPr lang="en-US" smtClean="0"/>
               <a:t>Second level</a:t>
             </a:r>
           </a:p>
           <a:p>
             <a:pPr lvl="2"/>
             <a:r>
-              <a:rPr lang="en-US"/>
+              <a:rPr lang="en-US" smtClean="0"/>
               <a:t>Third level</a:t>
             </a:r>
           </a:p>
           <a:p>
             <a:pPr lvl="3"/>
             <a:r>
-              <a:rPr lang="en-US"/>
+              <a:rPr lang="en-US" smtClean="0"/>
               <a:t>Fourth level</a:t>
             </a:r>
           </a:p>
           <a:p>
             <a:pPr lvl="4"/>
             <a:r>
-              <a:rPr lang="en-US"/>
+              <a:rPr lang="en-US" smtClean="0"/>
               <a:t>Fifth level</a:t>
             </a:r>
+            <a:endParaRPr lang="en-US"/>
           </a:p>
         </p:txBody>
       </p:sp>
@@ -411,7 +408,7 @@
           <a:p>
             <a:fld id="{5CD31FE7-93CC-4E45-AF1D-A5855231BD86}" type="datetimeFigureOut">
               <a:rPr lang="en-US" smtClean="0"/>
-              <a:t>10/20/2025</a:t>
+              <a:t>1/13/2016</a:t>
             </a:fld>
             <a:endParaRPr lang="en-US"/>
           </a:p>
@@ -510,9 +507,10 @@
           <a:lstStyle/>
           <a:p>
             <a:r>
-              <a:rPr lang="en-US"/>
+              <a:rPr lang="en-US" smtClean="0"/>
               <a:t>Click to edit Master title style</a:t>
             </a:r>
+            <a:endParaRPr lang="en-US"/>
           </a:p>
         </p:txBody>
       </p:sp>
@@ -538,37 +536,38 @@
           <a:p>
             <a:pPr lvl="0"/>
             <a:r>
-              <a:rPr lang="en-US"/>
+              <a:rPr lang="en-US" smtClean="0"/>
               <a:t>Click to edit Master text styles</a:t>
             </a:r>
           </a:p>
           <a:p>
             <a:pPr lvl="1"/>
             <a:r>
-              <a:rPr lang="en-US"/>
+              <a:rPr lang="en-US" smtClean="0"/>
               <a:t>Second level</a:t>
             </a:r>
           </a:p>
           <a:p>
             <a:pPr lvl="2"/>
             <a:r>
-              <a:rPr lang="en-US"/>
+              <a:rPr lang="en-US" smtClean="0"/>
               <a:t>Third level</a:t>
             </a:r>
           </a:p>
           <a:p>
             <a:pPr lvl="3"/>
             <a:r>
-              <a:rPr lang="en-US"/>
+              <a:rPr lang="en-US" smtClean="0"/>
               <a:t>Fourth level</a:t>
             </a:r>
           </a:p>
           <a:p>
             <a:pPr lvl="4"/>
             <a:r>
-              <a:rPr lang="en-US"/>
+              <a:rPr lang="en-US" smtClean="0"/>
               <a:t>Fifth level</a:t>
             </a:r>
+            <a:endParaRPr lang="en-US"/>
           </a:p>
         </p:txBody>
       </p:sp>
@@ -589,7 +588,7 @@
           <a:p>
             <a:fld id="{5CD31FE7-93CC-4E45-AF1D-A5855231BD86}" type="datetimeFigureOut">
               <a:rPr lang="en-US" smtClean="0"/>
-              <a:t>10/20/2025</a:t>
+              <a:t>1/13/2016</a:t>
             </a:fld>
             <a:endParaRPr lang="en-US"/>
           </a:p>
@@ -683,9 +682,10 @@
           <a:lstStyle/>
           <a:p>
             <a:r>
-              <a:rPr lang="en-US"/>
+              <a:rPr lang="en-US" smtClean="0"/>
               <a:t>Click to edit Master title style</a:t>
             </a:r>
+            <a:endParaRPr lang="en-US"/>
           </a:p>
         </p:txBody>
       </p:sp>
@@ -706,37 +706,38 @@
           <a:p>
             <a:pPr lvl="0"/>
             <a:r>
-              <a:rPr lang="en-US"/>
+              <a:rPr lang="en-US" smtClean="0"/>
               <a:t>Click to edit Master text styles</a:t>
             </a:r>
           </a:p>
           <a:p>
             <a:pPr lvl="1"/>
             <a:r>
-              <a:rPr lang="en-US"/>
+              <a:rPr lang="en-US" smtClean="0"/>
               <a:t>Second level</a:t>
             </a:r>
           </a:p>
           <a:p>
             <a:pPr lvl="2"/>
             <a:r>
-              <a:rPr lang="en-US"/>
+              <a:rPr lang="en-US" smtClean="0"/>
               <a:t>Third level</a:t>
             </a:r>
           </a:p>
           <a:p>
             <a:pPr lvl="3"/>
             <a:r>
-              <a:rPr lang="en-US"/>
+              <a:rPr lang="en-US" smtClean="0"/>
               <a:t>Fourth level</a:t>
             </a:r>
           </a:p>
           <a:p>
             <a:pPr lvl="4"/>
             <a:r>
-              <a:rPr lang="en-US"/>
+              <a:rPr lang="en-US" smtClean="0"/>
               <a:t>Fifth level</a:t>
             </a:r>
+            <a:endParaRPr lang="en-US"/>
           </a:p>
         </p:txBody>
       </p:sp>
@@ -757,7 +758,7 @@
           <a:p>
             <a:fld id="{5CD31FE7-93CC-4E45-AF1D-A5855231BD86}" type="datetimeFigureOut">
               <a:rPr lang="en-US" smtClean="0"/>
-              <a:t>10/20/2025</a:t>
+              <a:t>1/13/2016</a:t>
             </a:fld>
             <a:endParaRPr lang="en-US"/>
           </a:p>
@@ -860,9 +861,10 @@
           </a:lstStyle>
           <a:p>
             <a:r>
-              <a:rPr lang="en-US"/>
+              <a:rPr lang="en-US" smtClean="0"/>
               <a:t>Click to edit Master title style</a:t>
             </a:r>
+            <a:endParaRPr lang="en-US"/>
           </a:p>
         </p:txBody>
       </p:sp>
@@ -979,7 +981,7 @@
           <a:p>
             <a:pPr lvl="0"/>
             <a:r>
-              <a:rPr lang="en-US"/>
+              <a:rPr lang="en-US" smtClean="0"/>
               <a:t>Click to edit Master text styles</a:t>
             </a:r>
           </a:p>
@@ -1002,7 +1004,7 @@
           <a:p>
             <a:fld id="{5CD31FE7-93CC-4E45-AF1D-A5855231BD86}" type="datetimeFigureOut">
               <a:rPr lang="en-US" smtClean="0"/>
-              <a:t>10/20/2025</a:t>
+              <a:t>1/13/2016</a:t>
             </a:fld>
             <a:endParaRPr lang="en-US"/>
           </a:p>
@@ -1096,9 +1098,10 @@
           <a:lstStyle/>
           <a:p>
             <a:r>
-              <a:rPr lang="en-US"/>
+              <a:rPr lang="en-US" smtClean="0"/>
               <a:t>Click to edit Master title style</a:t>
             </a:r>
+            <a:endParaRPr lang="en-US"/>
           </a:p>
         </p:txBody>
       </p:sp>
@@ -1124,37 +1127,38 @@
           <a:p>
             <a:pPr lvl="0"/>
             <a:r>
-              <a:rPr lang="en-US"/>
+              <a:rPr lang="en-US" smtClean="0"/>
               <a:t>Click to edit Master text styles</a:t>
             </a:r>
           </a:p>
           <a:p>
             <a:pPr lvl="1"/>
             <a:r>
-              <a:rPr lang="en-US"/>
+              <a:rPr lang="en-US" smtClean="0"/>
               <a:t>Second level</a:t>
             </a:r>
           </a:p>
           <a:p>
             <a:pPr lvl="2"/>
             <a:r>
-              <a:rPr lang="en-US"/>
+              <a:rPr lang="en-US" smtClean="0"/>
               <a:t>Third level</a:t>
             </a:r>
           </a:p>
           <a:p>
             <a:pPr lvl="3"/>
             <a:r>
-              <a:rPr lang="en-US"/>
+              <a:rPr lang="en-US" smtClean="0"/>
               <a:t>Fourth level</a:t>
             </a:r>
           </a:p>
           <a:p>
             <a:pPr lvl="4"/>
             <a:r>
-              <a:rPr lang="en-US"/>
+              <a:rPr lang="en-US" smtClean="0"/>
               <a:t>Fifth level</a:t>
             </a:r>
+            <a:endParaRPr lang="en-US"/>
           </a:p>
         </p:txBody>
       </p:sp>
@@ -1180,37 +1184,38 @@
           <a:p>
             <a:pPr lvl="0"/>
             <a:r>
-              <a:rPr lang="en-US"/>
+              <a:rPr lang="en-US" smtClean="0"/>
               <a:t>Click to edit Master text styles</a:t>
             </a:r>
           </a:p>
           <a:p>
             <a:pPr lvl="1"/>
             <a:r>
-              <a:rPr lang="en-US"/>
+              <a:rPr lang="en-US" smtClean="0"/>
               <a:t>Second level</a:t>
             </a:r>
           </a:p>
           <a:p>
             <a:pPr lvl="2"/>
             <a:r>
-              <a:rPr lang="en-US"/>
+              <a:rPr lang="en-US" smtClean="0"/>
               <a:t>Third level</a:t>
             </a:r>
           </a:p>
           <a:p>
             <a:pPr lvl="3"/>
             <a:r>
-              <a:rPr lang="en-US"/>
+              <a:rPr lang="en-US" smtClean="0"/>
               <a:t>Fourth level</a:t>
             </a:r>
           </a:p>
           <a:p>
             <a:pPr lvl="4"/>
             <a:r>
-              <a:rPr lang="en-US"/>
+              <a:rPr lang="en-US" smtClean="0"/>
               <a:t>Fifth level</a:t>
             </a:r>
+            <a:endParaRPr lang="en-US"/>
           </a:p>
         </p:txBody>
       </p:sp>
@@ -1231,7 +1236,7 @@
           <a:p>
             <a:fld id="{5CD31FE7-93CC-4E45-AF1D-A5855231BD86}" type="datetimeFigureOut">
               <a:rPr lang="en-US" smtClean="0"/>
-              <a:t>10/20/2025</a:t>
+              <a:t>1/13/2016</a:t>
             </a:fld>
             <a:endParaRPr lang="en-US"/>
           </a:p>
@@ -1330,9 +1335,10 @@
           <a:lstStyle/>
           <a:p>
             <a:r>
-              <a:rPr lang="en-US"/>
+              <a:rPr lang="en-US" smtClean="0"/>
               <a:t>Click to edit Master title style</a:t>
             </a:r>
+            <a:endParaRPr lang="en-US"/>
           </a:p>
         </p:txBody>
       </p:sp>
@@ -1395,7 +1401,7 @@
           <a:p>
             <a:pPr lvl="0"/>
             <a:r>
-              <a:rPr lang="en-US"/>
+              <a:rPr lang="en-US" smtClean="0"/>
               <a:t>Click to edit Master text styles</a:t>
             </a:r>
           </a:p>
@@ -1423,37 +1429,38 @@
           <a:p>
             <a:pPr lvl="0"/>
             <a:r>
-              <a:rPr lang="en-US"/>
+              <a:rPr lang="en-US" smtClean="0"/>
               <a:t>Click to edit Master text styles</a:t>
             </a:r>
           </a:p>
           <a:p>
             <a:pPr lvl="1"/>
             <a:r>
-              <a:rPr lang="en-US"/>
+              <a:rPr lang="en-US" smtClean="0"/>
               <a:t>Second level</a:t>
             </a:r>
           </a:p>
           <a:p>
             <a:pPr lvl="2"/>
             <a:r>
-              <a:rPr lang="en-US"/>
+              <a:rPr lang="en-US" smtClean="0"/>
               <a:t>Third level</a:t>
             </a:r>
           </a:p>
           <a:p>
             <a:pPr lvl="3"/>
             <a:r>
-              <a:rPr lang="en-US"/>
+              <a:rPr lang="en-US" smtClean="0"/>
               <a:t>Fourth level</a:t>
             </a:r>
           </a:p>
           <a:p>
             <a:pPr lvl="4"/>
             <a:r>
-              <a:rPr lang="en-US"/>
+              <a:rPr lang="en-US" smtClean="0"/>
               <a:t>Fifth level</a:t>
             </a:r>
+            <a:endParaRPr lang="en-US"/>
           </a:p>
         </p:txBody>
       </p:sp>
@@ -1516,7 +1523,7 @@
           <a:p>
             <a:pPr lvl="0"/>
             <a:r>
-              <a:rPr lang="en-US"/>
+              <a:rPr lang="en-US" smtClean="0"/>
               <a:t>Click to edit Master text styles</a:t>
             </a:r>
           </a:p>
@@ -1544,37 +1551,38 @@
           <a:p>
             <a:pPr lvl="0"/>
             <a:r>
-              <a:rPr lang="en-US"/>
+              <a:rPr lang="en-US" smtClean="0"/>
               <a:t>Click to edit Master text styles</a:t>
             </a:r>
           </a:p>
           <a:p>
             <a:pPr lvl="1"/>
             <a:r>
-              <a:rPr lang="en-US"/>
+              <a:rPr lang="en-US" smtClean="0"/>
               <a:t>Second level</a:t>
             </a:r>
           </a:p>
           <a:p>
             <a:pPr lvl="2"/>
             <a:r>
-              <a:rPr lang="en-US"/>
+              <a:rPr lang="en-US" smtClean="0"/>
               <a:t>Third level</a:t>
             </a:r>
           </a:p>
           <a:p>
             <a:pPr lvl="3"/>
             <a:r>
-              <a:rPr lang="en-US"/>
+              <a:rPr lang="en-US" smtClean="0"/>
               <a:t>Fourth level</a:t>
             </a:r>
           </a:p>
           <a:p>
             <a:pPr lvl="4"/>
             <a:r>
-              <a:rPr lang="en-US"/>
+              <a:rPr lang="en-US" smtClean="0"/>
               <a:t>Fifth level</a:t>
             </a:r>
+            <a:endParaRPr lang="en-US"/>
           </a:p>
         </p:txBody>
       </p:sp>
@@ -1595,7 +1603,7 @@
           <a:p>
             <a:fld id="{5CD31FE7-93CC-4E45-AF1D-A5855231BD86}" type="datetimeFigureOut">
               <a:rPr lang="en-US" smtClean="0"/>
-              <a:t>10/20/2025</a:t>
+              <a:t>1/13/2016</a:t>
             </a:fld>
             <a:endParaRPr lang="en-US"/>
           </a:p>
@@ -1689,9 +1697,10 @@
           <a:lstStyle/>
           <a:p>
             <a:r>
-              <a:rPr lang="en-US"/>
+              <a:rPr lang="en-US" smtClean="0"/>
               <a:t>Click to edit Master title style</a:t>
             </a:r>
+            <a:endParaRPr lang="en-US"/>
           </a:p>
         </p:txBody>
       </p:sp>
@@ -1712,7 +1721,7 @@
           <a:p>
             <a:fld id="{5CD31FE7-93CC-4E45-AF1D-A5855231BD86}" type="datetimeFigureOut">
               <a:rPr lang="en-US" smtClean="0"/>
-              <a:t>10/20/2025</a:t>
+              <a:t>1/13/2016</a:t>
             </a:fld>
             <a:endParaRPr lang="en-US"/>
           </a:p>
@@ -1807,7 +1816,7 @@
           <a:p>
             <a:fld id="{5CD31FE7-93CC-4E45-AF1D-A5855231BD86}" type="datetimeFigureOut">
               <a:rPr lang="en-US" smtClean="0"/>
-              <a:t>10/20/2025</a:t>
+              <a:t>1/13/2016</a:t>
             </a:fld>
             <a:endParaRPr lang="en-US"/>
           </a:p>
@@ -1910,9 +1919,10 @@
           </a:lstStyle>
           <a:p>
             <a:r>
-              <a:rPr lang="en-US"/>
+              <a:rPr lang="en-US" smtClean="0"/>
               <a:t>Click to edit Master title style</a:t>
             </a:r>
+            <a:endParaRPr lang="en-US"/>
           </a:p>
         </p:txBody>
       </p:sp>
@@ -1966,37 +1976,38 @@
           <a:p>
             <a:pPr lvl="0"/>
             <a:r>
-              <a:rPr lang="en-US"/>
+              <a:rPr lang="en-US" smtClean="0"/>
               <a:t>Click to edit Master text styles</a:t>
             </a:r>
           </a:p>
           <a:p>
             <a:pPr lvl="1"/>
             <a:r>
-              <a:rPr lang="en-US"/>
+              <a:rPr lang="en-US" smtClean="0"/>
               <a:t>Second level</a:t>
             </a:r>
           </a:p>
           <a:p>
             <a:pPr lvl="2"/>
             <a:r>
-              <a:rPr lang="en-US"/>
+              <a:rPr lang="en-US" smtClean="0"/>
               <a:t>Third level</a:t>
             </a:r>
           </a:p>
           <a:p>
             <a:pPr lvl="3"/>
             <a:r>
-              <a:rPr lang="en-US"/>
+              <a:rPr lang="en-US" smtClean="0"/>
               <a:t>Fourth level</a:t>
             </a:r>
           </a:p>
           <a:p>
             <a:pPr lvl="4"/>
             <a:r>
-              <a:rPr lang="en-US"/>
+              <a:rPr lang="en-US" smtClean="0"/>
               <a:t>Fifth level</a:t>
             </a:r>
+            <a:endParaRPr lang="en-US"/>
           </a:p>
         </p:txBody>
       </p:sp>
@@ -2059,7 +2070,7 @@
           <a:p>
             <a:pPr lvl="0"/>
             <a:r>
-              <a:rPr lang="en-US"/>
+              <a:rPr lang="en-US" smtClean="0"/>
               <a:t>Click to edit Master text styles</a:t>
             </a:r>
           </a:p>
@@ -2082,7 +2093,7 @@
           <a:p>
             <a:fld id="{5CD31FE7-93CC-4E45-AF1D-A5855231BD86}" type="datetimeFigureOut">
               <a:rPr lang="en-US" smtClean="0"/>
-              <a:t>10/20/2025</a:t>
+              <a:t>1/13/2016</a:t>
             </a:fld>
             <a:endParaRPr lang="en-US"/>
           </a:p>
@@ -2185,9 +2196,10 @@
           </a:lstStyle>
           <a:p>
             <a:r>
-              <a:rPr lang="en-US"/>
+              <a:rPr lang="en-US" smtClean="0"/>
               <a:t>Click to edit Master title style</a:t>
             </a:r>
+            <a:endParaRPr lang="en-US"/>
           </a:p>
         </p:txBody>
       </p:sp>
@@ -2311,7 +2323,7 @@
           <a:p>
             <a:pPr lvl="0"/>
             <a:r>
-              <a:rPr lang="en-US"/>
+              <a:rPr lang="en-US" smtClean="0"/>
               <a:t>Click to edit Master text styles</a:t>
             </a:r>
           </a:p>
@@ -2334,7 +2346,7 @@
           <a:p>
             <a:fld id="{5CD31FE7-93CC-4E45-AF1D-A5855231BD86}" type="datetimeFigureOut">
               <a:rPr lang="en-US" smtClean="0"/>
-              <a:t>10/20/2025</a:t>
+              <a:t>1/13/2016</a:t>
             </a:fld>
             <a:endParaRPr lang="en-US"/>
           </a:p>
@@ -2443,9 +2455,10 @@
           <a:lstStyle/>
           <a:p>
             <a:r>
-              <a:rPr lang="en-US"/>
+              <a:rPr lang="en-US" smtClean="0"/>
               <a:t>Click to edit Master title style</a:t>
             </a:r>
+            <a:endParaRPr lang="en-US"/>
           </a:p>
         </p:txBody>
       </p:sp>
@@ -2476,37 +2489,38 @@
           <a:p>
             <a:pPr lvl="0"/>
             <a:r>
-              <a:rPr lang="en-US"/>
+              <a:rPr lang="en-US" smtClean="0"/>
               <a:t>Click to edit Master text styles</a:t>
             </a:r>
           </a:p>
           <a:p>
             <a:pPr lvl="1"/>
             <a:r>
-              <a:rPr lang="en-US"/>
+              <a:rPr lang="en-US" smtClean="0"/>
               <a:t>Second level</a:t>
             </a:r>
           </a:p>
           <a:p>
             <a:pPr lvl="2"/>
             <a:r>
-              <a:rPr lang="en-US"/>
+              <a:rPr lang="en-US" smtClean="0"/>
               <a:t>Third level</a:t>
             </a:r>
           </a:p>
           <a:p>
             <a:pPr lvl="3"/>
             <a:r>
-              <a:rPr lang="en-US"/>
+              <a:rPr lang="en-US" smtClean="0"/>
               <a:t>Fourth level</a:t>
             </a:r>
           </a:p>
           <a:p>
             <a:pPr lvl="4"/>
             <a:r>
-              <a:rPr lang="en-US"/>
+              <a:rPr lang="en-US" smtClean="0"/>
               <a:t>Fifth level</a:t>
             </a:r>
+            <a:endParaRPr lang="en-US"/>
           </a:p>
         </p:txBody>
       </p:sp>
@@ -2545,7 +2559,7 @@
           <a:p>
             <a:fld id="{5CD31FE7-93CC-4E45-AF1D-A5855231BD86}" type="datetimeFigureOut">
               <a:rPr lang="en-US" smtClean="0"/>
-              <a:t>10/20/2025</a:t>
+              <a:t>1/13/2016</a:t>
             </a:fld>
             <a:endParaRPr lang="en-US"/>
           </a:p>
@@ -3196,1156 +3210,10 @@
           </a:p>
         </p:txBody>
       </p:sp>
-      <p:sp>
-        <p:nvSpPr>
-          <p:cNvPr id="2" name="TextBox 1">
-            <a:extLst>
-              <a:ext uri="{FF2B5EF4-FFF2-40B4-BE49-F238E27FC236}">
-                <a16:creationId xmlns:a16="http://schemas.microsoft.com/office/drawing/2014/main" id="{4EE820DC-96A9-B534-8522-75210D478B3E}"/>
-              </a:ext>
-            </a:extLst>
-          </p:cNvPr>
-          <p:cNvSpPr txBox="1"/>
-          <p:nvPr/>
-        </p:nvSpPr>
-        <p:spPr>
-          <a:xfrm>
-            <a:off x="1211580" y="545815"/>
-            <a:ext cx="3634740" cy="369332"/>
-          </a:xfrm>
-          <a:prstGeom prst="rect">
-            <a:avLst/>
-          </a:prstGeom>
-          <a:noFill/>
-        </p:spPr>
-        <p:txBody>
-          <a:bodyPr wrap="square" rtlCol="0">
-            <a:spAutoFit/>
-          </a:bodyPr>
-          <a:lstStyle/>
-          <a:p>
-            <a:r>
-              <a:rPr lang="en-US" dirty="0"/>
-              <a:t>Original</a:t>
-            </a:r>
-          </a:p>
-        </p:txBody>
-      </p:sp>
     </p:spTree>
     <p:extLst>
       <p:ext uri="{BB962C8B-B14F-4D97-AF65-F5344CB8AC3E}">
         <p14:creationId xmlns:p14="http://schemas.microsoft.com/office/powerpoint/2010/main" val="3223732427"/>
-      </p:ext>
-    </p:extLst>
-  </p:cSld>
-  <p:clrMapOvr>
-    <a:masterClrMapping/>
-  </p:clrMapOvr>
-</p:sld>
-</file>
-
-<file path=ppt/slides/slide2.xml><?xml version="1.0" encoding="utf-8"?>
-<p:sld xmlns:a="http://schemas.openxmlformats.org/drawingml/2006/main" xmlns:r="http://schemas.openxmlformats.org/officeDocument/2006/relationships" xmlns:p="http://schemas.openxmlformats.org/presentationml/2006/main">
-  <p:cSld>
-    <p:spTree>
-      <p:nvGrpSpPr>
-        <p:cNvPr id="1" name="">
-          <a:extLst>
-            <a:ext uri="{FF2B5EF4-FFF2-40B4-BE49-F238E27FC236}">
-              <a16:creationId xmlns:a16="http://schemas.microsoft.com/office/drawing/2014/main" id="{E6958114-6E4B-ADDD-A014-F7F7DA8A7D0E}"/>
-            </a:ext>
-          </a:extLst>
-        </p:cNvPr>
-        <p:cNvGrpSpPr/>
-        <p:nvPr/>
-      </p:nvGrpSpPr>
-      <p:grpSpPr>
-        <a:xfrm>
-          <a:off x="0" y="0"/>
-          <a:ext cx="0" cy="0"/>
-          <a:chOff x="0" y="0"/>
-          <a:chExt cx="0" cy="0"/>
-        </a:xfrm>
-      </p:grpSpPr>
-      <p:sp>
-        <p:nvSpPr>
-          <p:cNvPr id="4" name="Rectangle 3">
-            <a:extLst>
-              <a:ext uri="{FF2B5EF4-FFF2-40B4-BE49-F238E27FC236}">
-                <a16:creationId xmlns:a16="http://schemas.microsoft.com/office/drawing/2014/main" id="{9583ECE3-4B3C-1182-DA02-F6BEA0B7F7E1}"/>
-              </a:ext>
-            </a:extLst>
-          </p:cNvPr>
-          <p:cNvSpPr>
-            <a:spLocks noChangeAspect="1"/>
-          </p:cNvSpPr>
-          <p:nvPr/>
-        </p:nvSpPr>
-        <p:spPr>
-          <a:xfrm>
-            <a:off x="1802562" y="2649564"/>
-            <a:ext cx="2253082" cy="2254435"/>
-          </a:xfrm>
-          <a:prstGeom prst="rect">
-            <a:avLst/>
-          </a:prstGeom>
-          <a:solidFill>
-            <a:schemeClr val="accent5">
-              <a:lumMod val="75000"/>
-            </a:schemeClr>
-          </a:solidFill>
-          <a:ln>
-            <a:noFill/>
-          </a:ln>
-        </p:spPr>
-        <p:style>
-          <a:lnRef idx="2">
-            <a:schemeClr val="accent1">
-              <a:shade val="50000"/>
-            </a:schemeClr>
-          </a:lnRef>
-          <a:fillRef idx="1">
-            <a:schemeClr val="accent1"/>
-          </a:fillRef>
-          <a:effectRef idx="0">
-            <a:schemeClr val="accent1"/>
-          </a:effectRef>
-          <a:fontRef idx="minor">
-            <a:schemeClr val="lt1"/>
-          </a:fontRef>
-        </p:style>
-        <p:txBody>
-          <a:bodyPr rtlCol="0" anchor="ctr"/>
-          <a:lstStyle/>
-          <a:p>
-            <a:pPr algn="ctr"/>
-            <a:endParaRPr lang="en-US"/>
-          </a:p>
-        </p:txBody>
-      </p:sp>
-      <p:sp>
-        <p:nvSpPr>
-          <p:cNvPr id="11" name="Block Arc 10">
-            <a:extLst>
-              <a:ext uri="{FF2B5EF4-FFF2-40B4-BE49-F238E27FC236}">
-                <a16:creationId xmlns:a16="http://schemas.microsoft.com/office/drawing/2014/main" id="{57D60D29-80DE-D2C0-06E5-ACB982393C4F}"/>
-              </a:ext>
-            </a:extLst>
-          </p:cNvPr>
-          <p:cNvSpPr/>
-          <p:nvPr/>
-        </p:nvSpPr>
-        <p:spPr>
-          <a:xfrm rot="8272644">
-            <a:off x="2098132" y="2965356"/>
-            <a:ext cx="1622854" cy="1622854"/>
-          </a:xfrm>
-          <a:prstGeom prst="blockArc">
-            <a:avLst>
-              <a:gd name="adj1" fmla="val 10800000"/>
-              <a:gd name="adj2" fmla="val 83578"/>
-              <a:gd name="adj3" fmla="val 8236"/>
-            </a:avLst>
-          </a:prstGeom>
-          <a:solidFill>
-            <a:schemeClr val="bg1"/>
-          </a:solidFill>
-          <a:ln>
-            <a:noFill/>
-          </a:ln>
-        </p:spPr>
-        <p:style>
-          <a:lnRef idx="2">
-            <a:schemeClr val="accent1">
-              <a:shade val="50000"/>
-            </a:schemeClr>
-          </a:lnRef>
-          <a:fillRef idx="1">
-            <a:schemeClr val="accent1"/>
-          </a:fillRef>
-          <a:effectRef idx="0">
-            <a:schemeClr val="accent1"/>
-          </a:effectRef>
-          <a:fontRef idx="minor">
-            <a:schemeClr val="lt1"/>
-          </a:fontRef>
-        </p:style>
-        <p:txBody>
-          <a:bodyPr rtlCol="0" anchor="ctr"/>
-          <a:lstStyle/>
-          <a:p>
-            <a:pPr algn="ctr"/>
-            <a:endParaRPr lang="en-US">
-              <a:solidFill>
-                <a:schemeClr val="tx1"/>
-              </a:solidFill>
-            </a:endParaRPr>
-          </a:p>
-        </p:txBody>
-      </p:sp>
-      <p:sp>
-        <p:nvSpPr>
-          <p:cNvPr id="14" name="Oval 13">
-            <a:extLst>
-              <a:ext uri="{FF2B5EF4-FFF2-40B4-BE49-F238E27FC236}">
-                <a16:creationId xmlns:a16="http://schemas.microsoft.com/office/drawing/2014/main" id="{9E1EBBC2-34E5-1444-6B13-2FFC98D939CF}"/>
-              </a:ext>
-            </a:extLst>
-          </p:cNvPr>
-          <p:cNvSpPr/>
-          <p:nvPr/>
-        </p:nvSpPr>
-        <p:spPr>
-          <a:xfrm>
-            <a:off x="2799536" y="3666760"/>
-            <a:ext cx="220045" cy="220045"/>
-          </a:xfrm>
-          <a:prstGeom prst="ellipse">
-            <a:avLst/>
-          </a:prstGeom>
-          <a:solidFill>
-            <a:schemeClr val="bg1"/>
-          </a:solidFill>
-          <a:ln>
-            <a:noFill/>
-          </a:ln>
-        </p:spPr>
-        <p:style>
-          <a:lnRef idx="2">
-            <a:schemeClr val="accent1">
-              <a:shade val="50000"/>
-            </a:schemeClr>
-          </a:lnRef>
-          <a:fillRef idx="1">
-            <a:schemeClr val="accent1"/>
-          </a:fillRef>
-          <a:effectRef idx="0">
-            <a:schemeClr val="accent1"/>
-          </a:effectRef>
-          <a:fontRef idx="minor">
-            <a:schemeClr val="lt1"/>
-          </a:fontRef>
-        </p:style>
-        <p:txBody>
-          <a:bodyPr rtlCol="0" anchor="ctr"/>
-          <a:lstStyle/>
-          <a:p>
-            <a:pPr algn="ctr"/>
-            <a:endParaRPr lang="en-US"/>
-          </a:p>
-        </p:txBody>
-      </p:sp>
-      <p:grpSp>
-        <p:nvGrpSpPr>
-          <p:cNvPr id="3" name="Group 2">
-            <a:extLst>
-              <a:ext uri="{FF2B5EF4-FFF2-40B4-BE49-F238E27FC236}">
-                <a16:creationId xmlns:a16="http://schemas.microsoft.com/office/drawing/2014/main" id="{FD2EAA0C-4B5E-4AE9-87AF-D52F9F588E62}"/>
-              </a:ext>
-            </a:extLst>
-          </p:cNvPr>
-          <p:cNvGrpSpPr/>
-          <p:nvPr/>
-        </p:nvGrpSpPr>
-        <p:grpSpPr>
-          <a:xfrm>
-            <a:off x="2271727" y="3180610"/>
-            <a:ext cx="1472939" cy="761526"/>
-            <a:chOff x="2096630" y="1945197"/>
-            <a:chExt cx="1472939" cy="761526"/>
-          </a:xfrm>
-          <a:solidFill>
-            <a:schemeClr val="accent4"/>
-          </a:solidFill>
-        </p:grpSpPr>
-        <p:sp>
-          <p:nvSpPr>
-            <p:cNvPr id="13" name="Down Arrow 12">
-              <a:extLst>
-                <a:ext uri="{FF2B5EF4-FFF2-40B4-BE49-F238E27FC236}">
-                  <a16:creationId xmlns:a16="http://schemas.microsoft.com/office/drawing/2014/main" id="{F32DF13D-BEA6-0C3B-51CF-CA2FA3692F5F}"/>
-                </a:ext>
-              </a:extLst>
-            </p:cNvPr>
-            <p:cNvSpPr/>
-            <p:nvPr/>
-          </p:nvSpPr>
-          <p:spPr>
-            <a:xfrm rot="5147572">
-              <a:off x="2907343" y="2302363"/>
-              <a:ext cx="370703" cy="438018"/>
-            </a:xfrm>
-            <a:prstGeom prst="downArrow">
-              <a:avLst>
-                <a:gd name="adj1" fmla="val 32222"/>
-                <a:gd name="adj2" fmla="val 50000"/>
-              </a:avLst>
-            </a:prstGeom>
-            <a:grpFill/>
-            <a:ln>
-              <a:noFill/>
-            </a:ln>
-          </p:spPr>
-          <p:style>
-            <a:lnRef idx="2">
-              <a:schemeClr val="accent1">
-                <a:shade val="50000"/>
-              </a:schemeClr>
-            </a:lnRef>
-            <a:fillRef idx="1">
-              <a:schemeClr val="accent1"/>
-            </a:fillRef>
-            <a:effectRef idx="0">
-              <a:schemeClr val="accent1"/>
-            </a:effectRef>
-            <a:fontRef idx="minor">
-              <a:schemeClr val="lt1"/>
-            </a:fontRef>
-          </p:style>
-          <p:txBody>
-            <a:bodyPr rtlCol="0" anchor="ctr"/>
-            <a:lstStyle/>
-            <a:p>
-              <a:pPr algn="ctr"/>
-              <a:endParaRPr lang="en-US"/>
-            </a:p>
-          </p:txBody>
-        </p:sp>
-        <p:sp>
-          <p:nvSpPr>
-            <p:cNvPr id="2" name="Rectangle 1">
-              <a:extLst>
-                <a:ext uri="{FF2B5EF4-FFF2-40B4-BE49-F238E27FC236}">
-                  <a16:creationId xmlns:a16="http://schemas.microsoft.com/office/drawing/2014/main" id="{6F34C226-B9C7-773B-DEE6-26E2BBCE7830}"/>
-                </a:ext>
-              </a:extLst>
-            </p:cNvPr>
-            <p:cNvSpPr/>
-            <p:nvPr/>
-          </p:nvSpPr>
-          <p:spPr>
-            <a:xfrm rot="2651035">
-              <a:off x="2096630" y="1945197"/>
-              <a:ext cx="1472939" cy="124270"/>
-            </a:xfrm>
-            <a:prstGeom prst="rect">
-              <a:avLst/>
-            </a:prstGeom>
-            <a:grpFill/>
-            <a:ln>
-              <a:noFill/>
-            </a:ln>
-          </p:spPr>
-          <p:style>
-            <a:lnRef idx="2">
-              <a:schemeClr val="accent1">
-                <a:shade val="50000"/>
-              </a:schemeClr>
-            </a:lnRef>
-            <a:fillRef idx="1">
-              <a:schemeClr val="accent1"/>
-            </a:fillRef>
-            <a:effectRef idx="0">
-              <a:schemeClr val="accent1"/>
-            </a:effectRef>
-            <a:fontRef idx="minor">
-              <a:schemeClr val="lt1"/>
-            </a:fontRef>
-          </p:style>
-          <p:txBody>
-            <a:bodyPr rtlCol="0" anchor="ctr"/>
-            <a:lstStyle/>
-            <a:p>
-              <a:pPr algn="ctr"/>
-              <a:endParaRPr lang="en-US"/>
-            </a:p>
-          </p:txBody>
-        </p:sp>
-      </p:grpSp>
-      <p:grpSp>
-        <p:nvGrpSpPr>
-          <p:cNvPr id="5" name="Group 4">
-            <a:extLst>
-              <a:ext uri="{FF2B5EF4-FFF2-40B4-BE49-F238E27FC236}">
-                <a16:creationId xmlns:a16="http://schemas.microsoft.com/office/drawing/2014/main" id="{86308B53-7BBA-8C20-4475-788D47E87973}"/>
-              </a:ext>
-            </a:extLst>
-          </p:cNvPr>
-          <p:cNvGrpSpPr/>
-          <p:nvPr/>
-        </p:nvGrpSpPr>
-        <p:grpSpPr>
-          <a:xfrm rot="16200000" flipH="1">
-            <a:off x="1950081" y="3493863"/>
-            <a:ext cx="1468841" cy="760098"/>
-            <a:chOff x="2100149" y="1946625"/>
-            <a:chExt cx="1468841" cy="760098"/>
-          </a:xfrm>
-          <a:solidFill>
-            <a:schemeClr val="accent4"/>
-          </a:solidFill>
-        </p:grpSpPr>
-        <p:sp>
-          <p:nvSpPr>
-            <p:cNvPr id="6" name="Down Arrow 12">
-              <a:extLst>
-                <a:ext uri="{FF2B5EF4-FFF2-40B4-BE49-F238E27FC236}">
-                  <a16:creationId xmlns:a16="http://schemas.microsoft.com/office/drawing/2014/main" id="{BED825B6-F25D-ADFF-0B0C-58A3ECE5E78D}"/>
-                </a:ext>
-              </a:extLst>
-            </p:cNvPr>
-            <p:cNvSpPr/>
-            <p:nvPr/>
-          </p:nvSpPr>
-          <p:spPr>
-            <a:xfrm rot="5147572">
-              <a:off x="2907343" y="2302363"/>
-              <a:ext cx="370703" cy="438018"/>
-            </a:xfrm>
-            <a:prstGeom prst="downArrow">
-              <a:avLst>
-                <a:gd name="adj1" fmla="val 32222"/>
-                <a:gd name="adj2" fmla="val 50000"/>
-              </a:avLst>
-            </a:prstGeom>
-            <a:grpFill/>
-            <a:ln>
-              <a:noFill/>
-            </a:ln>
-          </p:spPr>
-          <p:style>
-            <a:lnRef idx="2">
-              <a:schemeClr val="accent1">
-                <a:shade val="50000"/>
-              </a:schemeClr>
-            </a:lnRef>
-            <a:fillRef idx="1">
-              <a:schemeClr val="accent1"/>
-            </a:fillRef>
-            <a:effectRef idx="0">
-              <a:schemeClr val="accent1"/>
-            </a:effectRef>
-            <a:fontRef idx="minor">
-              <a:schemeClr val="lt1"/>
-            </a:fontRef>
-          </p:style>
-          <p:txBody>
-            <a:bodyPr rtlCol="0" anchor="ctr"/>
-            <a:lstStyle/>
-            <a:p>
-              <a:pPr algn="ctr"/>
-              <a:endParaRPr lang="en-US"/>
-            </a:p>
-          </p:txBody>
-        </p:sp>
-        <p:sp>
-          <p:nvSpPr>
-            <p:cNvPr id="7" name="Rectangle 6">
-              <a:extLst>
-                <a:ext uri="{FF2B5EF4-FFF2-40B4-BE49-F238E27FC236}">
-                  <a16:creationId xmlns:a16="http://schemas.microsoft.com/office/drawing/2014/main" id="{3288AC96-1BA0-6FBD-C56E-960EACD240EE}"/>
-                </a:ext>
-              </a:extLst>
-            </p:cNvPr>
-            <p:cNvSpPr/>
-            <p:nvPr/>
-          </p:nvSpPr>
-          <p:spPr>
-            <a:xfrm rot="2651035">
-              <a:off x="2100149" y="1946625"/>
-              <a:ext cx="1468841" cy="124270"/>
-            </a:xfrm>
-            <a:prstGeom prst="rect">
-              <a:avLst/>
-            </a:prstGeom>
-            <a:grpFill/>
-            <a:ln>
-              <a:noFill/>
-            </a:ln>
-          </p:spPr>
-          <p:style>
-            <a:lnRef idx="2">
-              <a:schemeClr val="accent1">
-                <a:shade val="50000"/>
-              </a:schemeClr>
-            </a:lnRef>
-            <a:fillRef idx="1">
-              <a:schemeClr val="accent1"/>
-            </a:fillRef>
-            <a:effectRef idx="0">
-              <a:schemeClr val="accent1"/>
-            </a:effectRef>
-            <a:fontRef idx="minor">
-              <a:schemeClr val="lt1"/>
-            </a:fontRef>
-          </p:style>
-          <p:txBody>
-            <a:bodyPr rtlCol="0" anchor="ctr"/>
-            <a:lstStyle/>
-            <a:p>
-              <a:pPr algn="ctr"/>
-              <a:endParaRPr lang="en-US"/>
-            </a:p>
-          </p:txBody>
-        </p:sp>
-      </p:grpSp>
-      <p:sp>
-        <p:nvSpPr>
-          <p:cNvPr id="8" name="Partial Circle 7">
-            <a:extLst>
-              <a:ext uri="{FF2B5EF4-FFF2-40B4-BE49-F238E27FC236}">
-                <a16:creationId xmlns:a16="http://schemas.microsoft.com/office/drawing/2014/main" id="{29C09109-1E7C-6667-EE44-A02F4DDA8EC5}"/>
-              </a:ext>
-            </a:extLst>
-          </p:cNvPr>
-          <p:cNvSpPr/>
-          <p:nvPr/>
-        </p:nvSpPr>
-        <p:spPr>
-          <a:xfrm>
-            <a:off x="1002462" y="1849464"/>
-            <a:ext cx="1600200" cy="1600200"/>
-          </a:xfrm>
-          <a:prstGeom prst="pie">
-            <a:avLst>
-              <a:gd name="adj1" fmla="val 0"/>
-              <a:gd name="adj2" fmla="val 5419328"/>
-            </a:avLst>
-          </a:prstGeom>
-          <a:solidFill>
-            <a:schemeClr val="accent4"/>
-          </a:solidFill>
-          <a:ln>
-            <a:noFill/>
-          </a:ln>
-        </p:spPr>
-        <p:style>
-          <a:lnRef idx="2">
-            <a:schemeClr val="accent1">
-              <a:shade val="15000"/>
-            </a:schemeClr>
-          </a:lnRef>
-          <a:fillRef idx="1">
-            <a:schemeClr val="accent1"/>
-          </a:fillRef>
-          <a:effectRef idx="0">
-            <a:schemeClr val="accent1"/>
-          </a:effectRef>
-          <a:fontRef idx="minor">
-            <a:schemeClr val="lt1"/>
-          </a:fontRef>
-        </p:style>
-        <p:txBody>
-          <a:bodyPr rtlCol="0" anchor="ctr"/>
-          <a:lstStyle/>
-          <a:p>
-            <a:pPr algn="ctr"/>
-            <a:endParaRPr lang="en-US">
-              <a:solidFill>
-                <a:schemeClr val="tx1"/>
-              </a:solidFill>
-            </a:endParaRPr>
-          </a:p>
-        </p:txBody>
-      </p:sp>
-      <p:sp>
-        <p:nvSpPr>
-          <p:cNvPr id="9" name="TextBox 8">
-            <a:extLst>
-              <a:ext uri="{FF2B5EF4-FFF2-40B4-BE49-F238E27FC236}">
-                <a16:creationId xmlns:a16="http://schemas.microsoft.com/office/drawing/2014/main" id="{2188D3F2-6F95-F902-39E5-3711F6F05179}"/>
-              </a:ext>
-            </a:extLst>
-          </p:cNvPr>
-          <p:cNvSpPr txBox="1"/>
-          <p:nvPr/>
-        </p:nvSpPr>
-        <p:spPr>
-          <a:xfrm>
-            <a:off x="1105640" y="1960283"/>
-            <a:ext cx="3634740" cy="369332"/>
-          </a:xfrm>
-          <a:prstGeom prst="rect">
-            <a:avLst/>
-          </a:prstGeom>
-          <a:noFill/>
-        </p:spPr>
-        <p:txBody>
-          <a:bodyPr wrap="square" rtlCol="0">
-            <a:spAutoFit/>
-          </a:bodyPr>
-          <a:lstStyle/>
-          <a:p>
-            <a:r>
-              <a:rPr lang="en-US" dirty="0"/>
-              <a:t>Mock 1: Parabolic Trough</a:t>
-            </a:r>
-          </a:p>
-        </p:txBody>
-      </p:sp>
-    </p:spTree>
-    <p:extLst>
-      <p:ext uri="{BB962C8B-B14F-4D97-AF65-F5344CB8AC3E}">
-        <p14:creationId xmlns:p14="http://schemas.microsoft.com/office/powerpoint/2010/main" val="181606284"/>
-      </p:ext>
-    </p:extLst>
-  </p:cSld>
-  <p:clrMapOvr>
-    <a:masterClrMapping/>
-  </p:clrMapOvr>
-</p:sld>
-</file>
-
-<file path=ppt/slides/slide3.xml><?xml version="1.0" encoding="utf-8"?>
-<p:sld xmlns:a="http://schemas.openxmlformats.org/drawingml/2006/main" xmlns:r="http://schemas.openxmlformats.org/officeDocument/2006/relationships" xmlns:p="http://schemas.openxmlformats.org/presentationml/2006/main">
-  <p:cSld>
-    <p:spTree>
-      <p:nvGrpSpPr>
-        <p:cNvPr id="1" name="">
-          <a:extLst>
-            <a:ext uri="{FF2B5EF4-FFF2-40B4-BE49-F238E27FC236}">
-              <a16:creationId xmlns:a16="http://schemas.microsoft.com/office/drawing/2014/main" id="{04E4C1EE-B114-7534-2364-1E01D7C33FDC}"/>
-            </a:ext>
-          </a:extLst>
-        </p:cNvPr>
-        <p:cNvGrpSpPr/>
-        <p:nvPr/>
-      </p:nvGrpSpPr>
-      <p:grpSpPr>
-        <a:xfrm>
-          <a:off x="0" y="0"/>
-          <a:ext cx="0" cy="0"/>
-          <a:chOff x="0" y="0"/>
-          <a:chExt cx="0" cy="0"/>
-        </a:xfrm>
-      </p:grpSpPr>
-      <p:sp>
-        <p:nvSpPr>
-          <p:cNvPr id="4" name="Rectangle 3">
-            <a:extLst>
-              <a:ext uri="{FF2B5EF4-FFF2-40B4-BE49-F238E27FC236}">
-                <a16:creationId xmlns:a16="http://schemas.microsoft.com/office/drawing/2014/main" id="{4D19E992-849E-31FE-8008-1E7B3635CCC8}"/>
-              </a:ext>
-            </a:extLst>
-          </p:cNvPr>
-          <p:cNvSpPr>
-            <a:spLocks noChangeAspect="1"/>
-          </p:cNvSpPr>
-          <p:nvPr/>
-        </p:nvSpPr>
-        <p:spPr>
-          <a:xfrm>
-            <a:off x="1804195" y="2643849"/>
-            <a:ext cx="2253082" cy="2254435"/>
-          </a:xfrm>
-          <a:prstGeom prst="rect">
-            <a:avLst/>
-          </a:prstGeom>
-          <a:solidFill>
-            <a:schemeClr val="accent5">
-              <a:lumMod val="75000"/>
-            </a:schemeClr>
-          </a:solidFill>
-          <a:ln>
-            <a:noFill/>
-          </a:ln>
-        </p:spPr>
-        <p:style>
-          <a:lnRef idx="2">
-            <a:schemeClr val="accent1">
-              <a:shade val="50000"/>
-            </a:schemeClr>
-          </a:lnRef>
-          <a:fillRef idx="1">
-            <a:schemeClr val="accent1"/>
-          </a:fillRef>
-          <a:effectRef idx="0">
-            <a:schemeClr val="accent1"/>
-          </a:effectRef>
-          <a:fontRef idx="minor">
-            <a:schemeClr val="lt1"/>
-          </a:fontRef>
-        </p:style>
-        <p:txBody>
-          <a:bodyPr rtlCol="0" anchor="ctr"/>
-          <a:lstStyle/>
-          <a:p>
-            <a:pPr algn="ctr"/>
-            <a:endParaRPr lang="en-US"/>
-          </a:p>
-        </p:txBody>
-      </p:sp>
-      <p:sp>
-        <p:nvSpPr>
-          <p:cNvPr id="14" name="Oval 13">
-            <a:extLst>
-              <a:ext uri="{FF2B5EF4-FFF2-40B4-BE49-F238E27FC236}">
-                <a16:creationId xmlns:a16="http://schemas.microsoft.com/office/drawing/2014/main" id="{C3039E56-8937-D3B9-F984-69853B429529}"/>
-              </a:ext>
-            </a:extLst>
-          </p:cNvPr>
-          <p:cNvSpPr/>
-          <p:nvPr/>
-        </p:nvSpPr>
-        <p:spPr>
-          <a:xfrm>
-            <a:off x="2017522" y="3794049"/>
-            <a:ext cx="220045" cy="220045"/>
-          </a:xfrm>
-          <a:prstGeom prst="ellipse">
-            <a:avLst/>
-          </a:prstGeom>
-          <a:solidFill>
-            <a:schemeClr val="bg1"/>
-          </a:solidFill>
-          <a:ln>
-            <a:noFill/>
-          </a:ln>
-        </p:spPr>
-        <p:style>
-          <a:lnRef idx="2">
-            <a:schemeClr val="accent1">
-              <a:shade val="50000"/>
-            </a:schemeClr>
-          </a:lnRef>
-          <a:fillRef idx="1">
-            <a:schemeClr val="accent1"/>
-          </a:fillRef>
-          <a:effectRef idx="0">
-            <a:schemeClr val="accent1"/>
-          </a:effectRef>
-          <a:fontRef idx="minor">
-            <a:schemeClr val="lt1"/>
-          </a:fontRef>
-        </p:style>
-        <p:txBody>
-          <a:bodyPr rtlCol="0" anchor="ctr"/>
-          <a:lstStyle/>
-          <a:p>
-            <a:pPr algn="ctr"/>
-            <a:endParaRPr lang="en-US"/>
-          </a:p>
-        </p:txBody>
-      </p:sp>
-      <p:sp>
-        <p:nvSpPr>
-          <p:cNvPr id="13" name="Down Arrow 12">
-            <a:extLst>
-              <a:ext uri="{FF2B5EF4-FFF2-40B4-BE49-F238E27FC236}">
-                <a16:creationId xmlns:a16="http://schemas.microsoft.com/office/drawing/2014/main" id="{CEFB8E1D-2E3C-F7FB-8775-D7D998A65747}"/>
-              </a:ext>
-            </a:extLst>
-          </p:cNvPr>
-          <p:cNvSpPr/>
-          <p:nvPr/>
-        </p:nvSpPr>
-        <p:spPr>
-          <a:xfrm rot="5624428">
-            <a:off x="2842174" y="3283977"/>
-            <a:ext cx="147847" cy="1280160"/>
-          </a:xfrm>
-          <a:prstGeom prst="downArrow">
-            <a:avLst>
-              <a:gd name="adj1" fmla="val 52625"/>
-              <a:gd name="adj2" fmla="val 106547"/>
-            </a:avLst>
-          </a:prstGeom>
-          <a:solidFill>
-            <a:schemeClr val="accent4"/>
-          </a:solidFill>
-          <a:ln>
-            <a:noFill/>
-          </a:ln>
-        </p:spPr>
-        <p:style>
-          <a:lnRef idx="2">
-            <a:schemeClr val="accent1">
-              <a:shade val="50000"/>
-            </a:schemeClr>
-          </a:lnRef>
-          <a:fillRef idx="1">
-            <a:schemeClr val="accent1"/>
-          </a:fillRef>
-          <a:effectRef idx="0">
-            <a:schemeClr val="accent1"/>
-          </a:effectRef>
-          <a:fontRef idx="minor">
-            <a:schemeClr val="lt1"/>
-          </a:fontRef>
-        </p:style>
-        <p:txBody>
-          <a:bodyPr rtlCol="0" anchor="ctr"/>
-          <a:lstStyle/>
-          <a:p>
-            <a:pPr algn="ctr"/>
-            <a:endParaRPr lang="en-US"/>
-          </a:p>
-        </p:txBody>
-      </p:sp>
-      <p:sp>
-        <p:nvSpPr>
-          <p:cNvPr id="2" name="Rectangle 1">
-            <a:extLst>
-              <a:ext uri="{FF2B5EF4-FFF2-40B4-BE49-F238E27FC236}">
-                <a16:creationId xmlns:a16="http://schemas.microsoft.com/office/drawing/2014/main" id="{59368020-32A3-A7CA-9E06-19D9C4EA6944}"/>
-              </a:ext>
-            </a:extLst>
-          </p:cNvPr>
-          <p:cNvSpPr/>
-          <p:nvPr/>
-        </p:nvSpPr>
-        <p:spPr>
-          <a:xfrm rot="18088811">
-            <a:off x="3040960" y="4225267"/>
-            <a:ext cx="980765" cy="124270"/>
-          </a:xfrm>
-          <a:prstGeom prst="rect">
-            <a:avLst/>
-          </a:prstGeom>
-          <a:solidFill>
-            <a:schemeClr val="bg1"/>
-          </a:solidFill>
-          <a:ln>
-            <a:noFill/>
-          </a:ln>
-        </p:spPr>
-        <p:style>
-          <a:lnRef idx="2">
-            <a:schemeClr val="accent1">
-              <a:shade val="50000"/>
-            </a:schemeClr>
-          </a:lnRef>
-          <a:fillRef idx="1">
-            <a:schemeClr val="accent1"/>
-          </a:fillRef>
-          <a:effectRef idx="0">
-            <a:schemeClr val="accent1"/>
-          </a:effectRef>
-          <a:fontRef idx="minor">
-            <a:schemeClr val="lt1"/>
-          </a:fontRef>
-        </p:style>
-        <p:txBody>
-          <a:bodyPr rtlCol="0" anchor="ctr"/>
-          <a:lstStyle/>
-          <a:p>
-            <a:pPr algn="ctr"/>
-            <a:endParaRPr lang="en-US"/>
-          </a:p>
-        </p:txBody>
-      </p:sp>
-      <p:sp>
-        <p:nvSpPr>
-          <p:cNvPr id="7" name="Rectangle 6">
-            <a:extLst>
-              <a:ext uri="{FF2B5EF4-FFF2-40B4-BE49-F238E27FC236}">
-                <a16:creationId xmlns:a16="http://schemas.microsoft.com/office/drawing/2014/main" id="{02D4C188-730D-8A75-30B7-8AD88D2478E8}"/>
-              </a:ext>
-            </a:extLst>
-          </p:cNvPr>
-          <p:cNvSpPr/>
-          <p:nvPr/>
-        </p:nvSpPr>
-        <p:spPr>
-          <a:xfrm rot="13412630" flipH="1">
-            <a:off x="2317349" y="3422715"/>
-            <a:ext cx="1463040" cy="91440"/>
-          </a:xfrm>
-          <a:prstGeom prst="rect">
-            <a:avLst/>
-          </a:prstGeom>
-          <a:solidFill>
-            <a:schemeClr val="accent4"/>
-          </a:solidFill>
-          <a:ln>
-            <a:noFill/>
-          </a:ln>
-        </p:spPr>
-        <p:style>
-          <a:lnRef idx="2">
-            <a:schemeClr val="accent1">
-              <a:shade val="50000"/>
-            </a:schemeClr>
-          </a:lnRef>
-          <a:fillRef idx="1">
-            <a:schemeClr val="accent1"/>
-          </a:fillRef>
-          <a:effectRef idx="0">
-            <a:schemeClr val="accent1"/>
-          </a:effectRef>
-          <a:fontRef idx="minor">
-            <a:schemeClr val="lt1"/>
-          </a:fontRef>
-        </p:style>
-        <p:txBody>
-          <a:bodyPr rtlCol="0" anchor="ctr"/>
-          <a:lstStyle/>
-          <a:p>
-            <a:pPr algn="ctr"/>
-            <a:endParaRPr lang="en-US" dirty="0"/>
-          </a:p>
-        </p:txBody>
-      </p:sp>
-      <p:sp>
-        <p:nvSpPr>
-          <p:cNvPr id="8" name="Partial Circle 7">
-            <a:extLst>
-              <a:ext uri="{FF2B5EF4-FFF2-40B4-BE49-F238E27FC236}">
-                <a16:creationId xmlns:a16="http://schemas.microsoft.com/office/drawing/2014/main" id="{0ED39133-5BC2-17CD-F7DA-47692471B899}"/>
-              </a:ext>
-            </a:extLst>
-          </p:cNvPr>
-          <p:cNvSpPr/>
-          <p:nvPr/>
-        </p:nvSpPr>
-        <p:spPr>
-          <a:xfrm>
-            <a:off x="1002462" y="1849464"/>
-            <a:ext cx="1600200" cy="1600200"/>
-          </a:xfrm>
-          <a:prstGeom prst="pie">
-            <a:avLst>
-              <a:gd name="adj1" fmla="val 0"/>
-              <a:gd name="adj2" fmla="val 5419328"/>
-            </a:avLst>
-          </a:prstGeom>
-          <a:solidFill>
-            <a:schemeClr val="accent4"/>
-          </a:solidFill>
-          <a:ln>
-            <a:noFill/>
-          </a:ln>
-        </p:spPr>
-        <p:style>
-          <a:lnRef idx="2">
-            <a:schemeClr val="accent1">
-              <a:shade val="15000"/>
-            </a:schemeClr>
-          </a:lnRef>
-          <a:fillRef idx="1">
-            <a:schemeClr val="accent1"/>
-          </a:fillRef>
-          <a:effectRef idx="0">
-            <a:schemeClr val="accent1"/>
-          </a:effectRef>
-          <a:fontRef idx="minor">
-            <a:schemeClr val="lt1"/>
-          </a:fontRef>
-        </p:style>
-        <p:txBody>
-          <a:bodyPr rtlCol="0" anchor="ctr"/>
-          <a:lstStyle/>
-          <a:p>
-            <a:pPr algn="ctr"/>
-            <a:endParaRPr lang="en-US">
-              <a:solidFill>
-                <a:schemeClr val="tx1"/>
-              </a:solidFill>
-            </a:endParaRPr>
-          </a:p>
-        </p:txBody>
-      </p:sp>
-      <p:sp>
-        <p:nvSpPr>
-          <p:cNvPr id="9" name="TextBox 8">
-            <a:extLst>
-              <a:ext uri="{FF2B5EF4-FFF2-40B4-BE49-F238E27FC236}">
-                <a16:creationId xmlns:a16="http://schemas.microsoft.com/office/drawing/2014/main" id="{32D91759-B353-4E06-00C4-A8018ED4C118}"/>
-              </a:ext>
-            </a:extLst>
-          </p:cNvPr>
-          <p:cNvSpPr txBox="1"/>
-          <p:nvPr/>
-        </p:nvSpPr>
-        <p:spPr>
-          <a:xfrm>
-            <a:off x="1308498" y="1820109"/>
-            <a:ext cx="3634740" cy="369332"/>
-          </a:xfrm>
-          <a:prstGeom prst="rect">
-            <a:avLst/>
-          </a:prstGeom>
-          <a:noFill/>
-        </p:spPr>
-        <p:txBody>
-          <a:bodyPr wrap="square" rtlCol="0">
-            <a:spAutoFit/>
-          </a:bodyPr>
-          <a:lstStyle/>
-          <a:p>
-            <a:r>
-              <a:rPr lang="en-US" dirty="0"/>
-              <a:t>Mock 2: Heliostat</a:t>
-            </a:r>
-          </a:p>
-        </p:txBody>
-      </p:sp>
-      <p:sp>
-        <p:nvSpPr>
-          <p:cNvPr id="12" name="Rectangle 11">
-            <a:extLst>
-              <a:ext uri="{FF2B5EF4-FFF2-40B4-BE49-F238E27FC236}">
-                <a16:creationId xmlns:a16="http://schemas.microsoft.com/office/drawing/2014/main" id="{3F693AAA-0FCF-5894-A0DE-CAF6C244CC30}"/>
-              </a:ext>
-            </a:extLst>
-          </p:cNvPr>
-          <p:cNvSpPr/>
-          <p:nvPr/>
-        </p:nvSpPr>
-        <p:spPr>
-          <a:xfrm rot="13412630" flipH="1">
-            <a:off x="1853551" y="3879815"/>
-            <a:ext cx="1645920" cy="91440"/>
-          </a:xfrm>
-          <a:prstGeom prst="rect">
-            <a:avLst/>
-          </a:prstGeom>
-          <a:solidFill>
-            <a:schemeClr val="accent4"/>
-          </a:solidFill>
-          <a:ln>
-            <a:noFill/>
-          </a:ln>
-        </p:spPr>
-        <p:style>
-          <a:lnRef idx="2">
-            <a:schemeClr val="accent1">
-              <a:shade val="50000"/>
-            </a:schemeClr>
-          </a:lnRef>
-          <a:fillRef idx="1">
-            <a:schemeClr val="accent1"/>
-          </a:fillRef>
-          <a:effectRef idx="0">
-            <a:schemeClr val="accent1"/>
-          </a:effectRef>
-          <a:fontRef idx="minor">
-            <a:schemeClr val="lt1"/>
-          </a:fontRef>
-        </p:style>
-        <p:txBody>
-          <a:bodyPr rtlCol="0" anchor="ctr"/>
-          <a:lstStyle/>
-          <a:p>
-            <a:pPr algn="ctr"/>
-            <a:endParaRPr lang="en-US" dirty="0"/>
-          </a:p>
-        </p:txBody>
-      </p:sp>
-      <p:sp>
-        <p:nvSpPr>
-          <p:cNvPr id="15" name="Down Arrow 12">
-            <a:extLst>
-              <a:ext uri="{FF2B5EF4-FFF2-40B4-BE49-F238E27FC236}">
-                <a16:creationId xmlns:a16="http://schemas.microsoft.com/office/drawing/2014/main" id="{624ABBA7-C831-918E-45D8-A09F1C789905}"/>
-              </a:ext>
-            </a:extLst>
-          </p:cNvPr>
-          <p:cNvSpPr/>
-          <p:nvPr/>
-        </p:nvSpPr>
-        <p:spPr>
-          <a:xfrm rot="6950936">
-            <a:off x="2680657" y="3684038"/>
-            <a:ext cx="146304" cy="1122153"/>
-          </a:xfrm>
-          <a:prstGeom prst="downArrow">
-            <a:avLst>
-              <a:gd name="adj1" fmla="val 52625"/>
-              <a:gd name="adj2" fmla="val 106547"/>
-            </a:avLst>
-          </a:prstGeom>
-          <a:solidFill>
-            <a:schemeClr val="accent4"/>
-          </a:solidFill>
-          <a:ln>
-            <a:noFill/>
-          </a:ln>
-        </p:spPr>
-        <p:style>
-          <a:lnRef idx="2">
-            <a:schemeClr val="accent1">
-              <a:shade val="50000"/>
-            </a:schemeClr>
-          </a:lnRef>
-          <a:fillRef idx="1">
-            <a:schemeClr val="accent1"/>
-          </a:fillRef>
-          <a:effectRef idx="0">
-            <a:schemeClr val="accent1"/>
-          </a:effectRef>
-          <a:fontRef idx="minor">
-            <a:schemeClr val="lt1"/>
-          </a:fontRef>
-        </p:style>
-        <p:txBody>
-          <a:bodyPr rtlCol="0" anchor="ctr"/>
-          <a:lstStyle/>
-          <a:p>
-            <a:pPr algn="ctr"/>
-            <a:endParaRPr lang="en-US"/>
-          </a:p>
-        </p:txBody>
-      </p:sp>
-      <p:sp>
-        <p:nvSpPr>
-          <p:cNvPr id="16" name="Down Arrow 12">
-            <a:extLst>
-              <a:ext uri="{FF2B5EF4-FFF2-40B4-BE49-F238E27FC236}">
-                <a16:creationId xmlns:a16="http://schemas.microsoft.com/office/drawing/2014/main" id="{DB40320D-CD71-7EC8-836F-E8ED536CC26B}"/>
-              </a:ext>
-            </a:extLst>
-          </p:cNvPr>
-          <p:cNvSpPr/>
-          <p:nvPr/>
-        </p:nvSpPr>
-        <p:spPr>
-          <a:xfrm rot="18697211">
-            <a:off x="2783567" y="2930185"/>
-            <a:ext cx="147847" cy="1554480"/>
-          </a:xfrm>
-          <a:prstGeom prst="downArrow">
-            <a:avLst>
-              <a:gd name="adj1" fmla="val 52625"/>
-              <a:gd name="adj2" fmla="val 106547"/>
-            </a:avLst>
-          </a:prstGeom>
-          <a:solidFill>
-            <a:schemeClr val="accent4"/>
-          </a:solidFill>
-          <a:ln>
-            <a:noFill/>
-          </a:ln>
-        </p:spPr>
-        <p:style>
-          <a:lnRef idx="2">
-            <a:schemeClr val="accent1">
-              <a:shade val="50000"/>
-            </a:schemeClr>
-          </a:lnRef>
-          <a:fillRef idx="1">
-            <a:schemeClr val="accent1"/>
-          </a:fillRef>
-          <a:effectRef idx="0">
-            <a:schemeClr val="accent1"/>
-          </a:effectRef>
-          <a:fontRef idx="minor">
-            <a:schemeClr val="lt1"/>
-          </a:fontRef>
-        </p:style>
-        <p:txBody>
-          <a:bodyPr rtlCol="0" anchor="ctr"/>
-          <a:lstStyle/>
-          <a:p>
-            <a:pPr algn="ctr"/>
-            <a:endParaRPr lang="en-US"/>
-          </a:p>
-        </p:txBody>
-      </p:sp>
-    </p:spTree>
-    <p:extLst>
-      <p:ext uri="{BB962C8B-B14F-4D97-AF65-F5344CB8AC3E}">
-        <p14:creationId xmlns:p14="http://schemas.microsoft.com/office/powerpoint/2010/main" val="1765859184"/>
       </p:ext>
     </p:extLst>
   </p:cSld>
@@ -4614,10 +3482,4 @@
     </a:ext>
   </a:extLst>
 </a:theme>
-</file>
-
-<file path=docMetadata/LabelInfo.xml><?xml version="1.0" encoding="utf-8"?>
-<clbl:labelList xmlns:clbl="http://schemas.microsoft.com/office/2020/mipLabelMetadata">
-  <clbl:label id="{95965d95-ecc0-4720-b759-1f33c42ed7da}" enabled="1" method="Standard" siteId="{a0f29d7e-28cd-4f54-8442-7885aee7c080}" contentBits="0" removed="0"/>
-</clbl:labelList>
 </file>
</xml_diff>